<commit_message>
docs: unify logits error provenance and add curve slide
</commit_message>
<xml_diff>
--- a/report/答辩PPT_RepViT.pptx
+++ b/report/答辩PPT_RepViT.pptx
@@ -20,6 +20,7 @@
     <p:sldId id="268" r:id="rId19"/>
     <p:sldId id="269" r:id="rId20"/>
     <p:sldId id="270" r:id="rId21"/>
+    <p:sldId id="271" r:id="rId22"/>
   </p:sldIdLst>
   <p:sldSz cx="12192000" cy="6858000" type="screen4x3"/>
   <p:notesSz cx="6858000" cy="9144000"/>
@@ -6209,7 +6210,7 @@
                   <a:ea typeface="Consolas"/>
                   <a:cs typeface="Consolas"/>
                 </a:rPr>
-                <a:t>108 → 0</a:t>
+                <a:t>107 → 0</a:t>
               </a:r>
             </a:p>
           </p:txBody>
@@ -13965,6 +13966,234 @@
 </p:sld>
 </file>
 
+<file path=ppt/slides/slide16.xml><?xml version="1.0" encoding="utf-8"?>
+<p:sld xmlns:a="http://schemas.openxmlformats.org/drawingml/2006/main" xmlns:p="http://schemas.openxmlformats.org/presentationml/2006/main" xmlns:r="http://schemas.openxmlformats.org/officeDocument/2006/relationships">
+  <p:cSld>
+    <p:bg>
+      <p:bgPr>
+        <a:solidFill>
+          <a:srgbClr val="0F172A"/>
+        </a:solidFill>
+        <a:effectLst/>
+      </p:bgPr>
+    </p:bg>
+    <p:spTree>
+      <p:nvGrpSpPr>
+        <p:cNvPr id="1" name=""/>
+        <p:cNvGrpSpPr/>
+        <p:nvPr/>
+      </p:nvGrpSpPr>
+      <p:grpSpPr/>
+      <p:sp>
+        <p:nvSpPr>
+          <p:cNvPr id="2" name="TextBox 1"/>
+          <p:cNvSpPr txBox="1"/>
+          <p:nvPr/>
+        </p:nvSpPr>
+        <p:spPr>
+          <a:xfrm>
+            <a:off x="548640" y="274320"/>
+            <a:ext cx="10972800" cy="457200"/>
+          </a:xfrm>
+          <a:prstGeom prst="rect">
+            <a:avLst/>
+          </a:prstGeom>
+          <a:noFill/>
+        </p:spPr>
+        <p:txBody>
+          <a:bodyPr wrap="none">
+            <a:spAutoFit/>
+          </a:bodyPr>
+          <a:lstStyle/>
+          <a:p>
+            <a:pPr>
+              <a:defRPr sz="2800" b="1">
+                <a:solidFill>
+                  <a:srgbClr val="FFFFFF"/>
+                </a:solidFill>
+              </a:defRPr>
+            </a:pPr>
+            <a:r>
+              <a:t>训练曲线：40 epoch 过程与误差口径</a:t>
+            </a:r>
+          </a:p>
+        </p:txBody>
+      </p:sp>
+      <p:pic>
+        <p:nvPicPr>
+          <p:cNvPr id="3" name="Picture 2" descr="opt_compare.png"/>
+          <p:cNvPicPr>
+            <a:picLocks noChangeAspect="1"/>
+          </p:cNvPicPr>
+          <p:nvPr/>
+        </p:nvPicPr>
+        <p:blipFill>
+          <a:blip r:embed="rId2"/>
+          <a:stretch>
+            <a:fillRect/>
+          </a:stretch>
+        </p:blipFill>
+        <p:spPr>
+          <a:xfrm>
+            <a:off x="502920" y="914400"/>
+            <a:ext cx="7498079" cy="3899001"/>
+          </a:xfrm>
+          <a:prstGeom prst="rect">
+            <a:avLst/>
+          </a:prstGeom>
+        </p:spPr>
+      </p:pic>
+      <p:sp>
+        <p:nvSpPr>
+          <p:cNvPr id="4" name="TextBox 3"/>
+          <p:cNvSpPr txBox="1"/>
+          <p:nvPr/>
+        </p:nvSpPr>
+        <p:spPr>
+          <a:xfrm>
+            <a:off x="8183879" y="960120"/>
+            <a:ext cx="3474720" cy="5303520"/>
+          </a:xfrm>
+          <a:prstGeom prst="rect">
+            <a:avLst/>
+          </a:prstGeom>
+          <a:noFill/>
+        </p:spPr>
+        <p:txBody>
+          <a:bodyPr wrap="square">
+            <a:spAutoFit/>
+          </a:bodyPr>
+          <a:lstStyle/>
+          <a:p>
+            <a:pPr>
+              <a:spcAft>
+                <a:spcPts val="800"/>
+              </a:spcAft>
+              <a:defRPr sz="2000" b="1">
+                <a:solidFill>
+                  <a:srgbClr val="38BDF8"/>
+                </a:solidFill>
+              </a:defRPr>
+            </a:pPr>
+            <a:r>
+              <a:t>怎么看这张图</a:t>
+            </a:r>
+          </a:p>
+          <a:p>
+            <a:pPr>
+              <a:spcAft>
+                <a:spcPts val="800"/>
+              </a:spcAft>
+              <a:defRPr sz="1600" b="0">
+                <a:solidFill>
+                  <a:srgbClr val="E6EDF3"/>
+                </a:solidFill>
+              </a:defRPr>
+            </a:pPr>
+            <a:r>
+              <a:t>• 前 3 个 epoch 是 warmup，指标上升最快</a:t>
+            </a:r>
+          </a:p>
+          <a:p>
+            <a:pPr>
+              <a:spcAft>
+                <a:spcPts val="800"/>
+              </a:spcAft>
+              <a:defRPr sz="1600" b="0">
+                <a:solidFill>
+                  <a:srgbClr val="E6EDF3"/>
+                </a:solidFill>
+              </a:defRPr>
+            </a:pPr>
+            <a:r>
+              <a:t>• epoch 15 后进入平台，末段没有明显过拟合</a:t>
+            </a:r>
+          </a:p>
+          <a:p>
+            <a:pPr>
+              <a:spcAft>
+                <a:spcPts val="800"/>
+              </a:spcAft>
+              <a:defRPr sz="1600" b="0">
+                <a:solidFill>
+                  <a:srgbClr val="E6EDF3"/>
+                </a:solidFill>
+              </a:defRPr>
+            </a:pPr>
+            <a:r>
+              <a:t>• Mixup/CutMix 的 train loss 不能和 baseline 直接比，软标签会抬高损失</a:t>
+            </a:r>
+          </a:p>
+          <a:p>
+            <a:pPr>
+              <a:spcAft>
+                <a:spcPts val="800"/>
+              </a:spcAft>
+              <a:defRPr sz="2000" b="1">
+                <a:solidFill>
+                  <a:srgbClr val="FACC15"/>
+                </a:solidFill>
+              </a:defRPr>
+            </a:pPr>
+            <a:r>
+              <a:t>本页固定口径</a:t>
+            </a:r>
+          </a:p>
+          <a:p>
+            <a:pPr>
+              <a:spcAft>
+                <a:spcPts val="800"/>
+              </a:spcAft>
+              <a:defRPr sz="1500" b="0">
+                <a:solidFill>
+                  <a:srgbClr val="E6EDF3"/>
+                </a:solidFill>
+              </a:defRPr>
+            </a:pPr>
+            <a:r>
+              <a:t>Pet-37 迁移训练；Baseline 与 opt_combo；同一划分、seed=42、40 epoch；曲线文件：outputs/curves/opt_compare.png</a:t>
+            </a:r>
+          </a:p>
+          <a:p>
+            <a:pPr>
+              <a:spcAft>
+                <a:spcPts val="800"/>
+              </a:spcAft>
+              <a:defRPr sz="2000" b="1">
+                <a:solidFill>
+                  <a:srgbClr val="FACC15"/>
+                </a:solidFill>
+              </a:defRPr>
+            </a:pPr>
+            <a:r>
+              <a:t>误差分两类</a:t>
+            </a:r>
+          </a:p>
+          <a:p>
+            <a:pPr>
+              <a:spcAft>
+                <a:spcPts val="800"/>
+              </a:spcAft>
+              <a:defRPr sz="1500" b="0">
+                <a:solidFill>
+                  <a:srgbClr val="E6EDF3"/>
+                </a:solidFill>
+              </a:defRPr>
+            </a:pPr>
+            <a:r>
+              <a:t>重参数化：融合前后 PyTorch，32 张，max|Δ|=7.093e-06。 PyTorch↔ONNX：训练侧与部署侧代码分开；比较同一输入，n=12，max|Δ|=6.198883e-06（展示 6.199e-06）。</a:t>
+            </a:r>
+          </a:p>
+        </p:txBody>
+      </p:sp>
+    </p:spTree>
+  </p:cSld>
+  <p:clrMapOvr>
+    <a:masterClrMapping/>
+  </p:clrMapOvr>
+</p:sld>
+</file>
+
 <file path=ppt/slides/slide2.xml><?xml version="1.0" encoding="utf-8"?>
 <p:sld xmlns:a="http://schemas.openxmlformats.org/drawingml/2006/main" xmlns:r="http://schemas.openxmlformats.org/officeDocument/2006/relationships" xmlns:p="http://schemas.openxmlformats.org/presentationml/2006/main">
   <p:cSld>
@@ -15420,7 +15649,7 @@
                   <a:ea typeface="Microsoft YaHei"/>
                   <a:cs typeface="Microsoft YaHei"/>
                 </a:rPr>
-                <a:t>BN 108 → 0 · Conv 126 → 103</a:t>
+                <a:t>BN 107 → 0 · Conv 126 → 103</a:t>
               </a:r>
             </a:p>
           </p:txBody>

</xml_diff>